<commit_message>
Biologi kap 3: faktagranskning, rättningar och ombyggda material
Rödlistedata verifierad (Rödlistan 2025), pollineringsnyans, fjällräv, nyckelfigur, lättläst-ikoner, Jeopardy mobil, PPT-bilder större, provet och lärarversioner ombyggda.

Co-Authored-By: Claude Sonnet 5.5 <noreply@anthropic.com>
Claude-Session: https://claude.ai/code/session_017mqJrSEX6tzqa8YfkctM6P
</commit_message>
<xml_diff>
--- a/planering/biologi-omrade3/biologi-3-0-introduktion-till-biologisk-mangfald.pptx
+++ b/planering/biologi-omrade3/biologi-3-0-introduktion-till-biologisk-mangfald.pptx
@@ -112,12 +112,12 @@
   <p:extLst>
     <p:ext uri="{521415D9-36F7-43E2-AB2F-B90AF26B5E84}">
       <p14:sectionLst xmlns:p14="http://schemas.microsoft.com/office/powerpoint/2010/main">
-        <p14:section name="Start" id="{104338d6-d69e-f971-e0ee-00770f1583df}">
+        <p14:section name="Start" id="{da6bf71c-8874-cf3a-3fb1-d33492834f75}">
           <p14:sldIdLst>
             <p14:sldId id="256"/>
           </p14:sldIdLst>
         </p14:section>
-        <p14:section name="Introduktion till biologisk mångfald" id="{0f593f0c-9219-148e-5d04-62d1d9e3c109}">
+        <p14:section name="Introduktion till biologisk mångfald" id="{e160703c-4d91-c53e-6388-18c7d807c0d5}">
           <p14:sldIdLst>
             <p14:sldId id="257"/>
             <p14:sldId id="258"/>

</xml_diff>